<commit_message>
2.0.0: simulated contestant opponents and the tiebreaker tie rule
Ties for first were scored as wins (pre-2014 co-champion rule), so Smart
Bet could recommend a tie-only bet ($6,000 instead of the $6,001 cover).
A k-way tie now scores 1/k of a win; nobody wins at $0.

Tier 2 and Daily Double rollouts now play opponents as simulated
contestants (engine/behavior.py, ADR-0003): role-based wager mixes from
Tesauro et al. (2013), 50% FJ accuracy, outcomes correlated at 0.3.
White paper, deck, technical docs and PDFs updated; llms.txt added.

Co-Authored-By: Claude Opus 5.5 <noreply@anthropic.com>
</commit_message>
<xml_diff>
--- a/docs/deck.pptx
+++ b/docs/deck.pptx
@@ -2134,7 +2134,7 @@
                 <a:ea typeface="Cambria" pitchFamily="34" charset="-122"/>
                 <a:cs typeface="Cambria" pitchFamily="34" charset="-120"/>
               </a:rPr>
-              <a:t>What's proven, what's a placeholder</a:t>
+              <a:t>What's proven, what's assumed</a:t>
             </a:r>
             <a:endParaRPr lang="en-US" sz="3200" dirty="0"/>
           </a:p>
@@ -2406,7 +2406,7 @@
                 <a:ea typeface="Calibri" pitchFamily="34" charset="-122"/>
                 <a:cs typeface="Calibri" pitchFamily="34" charset="-120"/>
               </a:rPr>
-              <a:t>30 automated tests, hand-derived where possible -- not just checked against the code's own output</a:t>
+              <a:t>Automated tests, hand-derived where possible -- not just checked against the code's own output</a:t>
             </a:r>
             <a:endParaRPr lang="en-US" sz="1300" dirty="0"/>
           </a:p>
@@ -2467,7 +2467,7 @@
                 <a:ea typeface="Cambria" pitchFamily="34" charset="-122"/>
                 <a:cs typeface="Cambria" pitchFamily="34" charset="-120"/>
               </a:rPr>
-              <a:t>PLACEHOLDER</a:t>
+              <a:t>ASSUMED</a:t>
             </a:r>
             <a:endParaRPr lang="en-US" sz="1600" dirty="0"/>
           </a:p>
@@ -2510,7 +2510,7 @@
                 <a:ea typeface="Calibri" pitchFamily="34" charset="-122"/>
                 <a:cs typeface="Calibri" pitchFamily="34" charset="-120"/>
               </a:rPr>
-              <a:t>How opponents actually tend to wager and answer -- a labeled guess, not fitted to real data yet</a:t>
+              <a:t>How rivals bet -- based on IBM's study of real games; some weights published, the rest labeled assumptions</a:t>
             </a:r>
             <a:endParaRPr lang="en-US" sz="1300" dirty="0"/>
           </a:p>
@@ -2596,7 +2596,7 @@
                 <a:ea typeface="Calibri" pitchFamily="34" charset="-122"/>
                 <a:cs typeface="Calibri" pitchFamily="34" charset="-120"/>
               </a:rPr>
-              <a:t>The JavaScript app's parity with the Python engine -- checked by hand, not by automated CI yet</a:t>
+              <a:t>The browser app is a hand-written copy of the engine -- compared against it by an automated script</a:t>
             </a:r>
             <a:endParaRPr lang="en-US" sz="1300" dirty="0"/>
           </a:p>
@@ -3371,15 +3371,9 @@
                 <a:latin typeface="Cambria" pitchFamily="34" charset="0"/>
                 <a:ea typeface="Cambria" pitchFamily="34" charset="-122"/>
                 <a:cs typeface="Cambria" pitchFamily="34" charset="-120"/>
-                <a:hlinkClick r:id="rId1" invalidUrl="" action="" tgtFrame="" tooltip="" history="1" highlightClick="0" endSnd="0">
-                  <a:extLst>
-                    <a:ext uri="{A12FA001-AC4F-418D-AE19-62706E023703}">
-                      <ahyp:hlinkClr xmlns:ahyp="http://schemas.microsoft.com/office/drawing/2018/hyperlinkcolor" val="tx"/>
-                    </a:ext>
-                  </a:extLst>
-                </a:hlinkClick>
-              </a:rPr>
-              <a:t>docs/white-paper.md</a:t>
+                <a:hlinkClick r:id="rId1"/>
+              </a:rPr>
+              <a:t>Read the white paper</a:t>
             </a:r>
             <a:endParaRPr lang="en-US" sz="2000" dirty="0"/>
           </a:p>
@@ -3417,8 +3411,9 @@
                 <a:latin typeface="Calibri" pitchFamily="34" charset="0"/>
                 <a:ea typeface="Calibri" pitchFamily="34" charset="-122"/>
                 <a:cs typeface="Calibri" pitchFamily="34" charset="-120"/>
-              </a:rPr>
-              <a:t>Also see: docs/tutorial/, docs/how-to/, docs/reference/, and docs/explanation/ for task-by-task guides</a:t>
+                <a:hlinkClick r:id="rId1"/>
+              </a:rPr>
+              <a:t>github.com/willhoop/jeopardy-wagering/blob/main/docs/white-paper.md</a:t>
             </a:r>
             <a:endParaRPr lang="en-US" sz="1200" dirty="0"/>
           </a:p>
@@ -4400,7 +4395,7 @@
                 <a:ea typeface="Calibri" pitchFamily="34" charset="-122"/>
                 <a:cs typeface="Calibri" pitchFamily="34" charset="-120"/>
               </a:rPr>
-              <a:t>A probability-weighted decision. Uses your confidence and a model of how opponents tend to play.</a:t>
+              <a:t>A probability-weighted decision. Uses your confidence and simulated rivals based on real games.</a:t>
             </a:r>
             <a:endParaRPr lang="en-US" sz="1400" dirty="0"/>
           </a:p>
@@ -5140,7 +5135,7 @@
                 <a:ea typeface="Cambria" pitchFamily="34" charset="-122"/>
                 <a:cs typeface="Cambria" pitchFamily="34" charset="-120"/>
               </a:rPr>
-              <a:t>Smart Bet: using your confidence</a:t>
+              <a:t>Smart Bet: a tie is not a win</a:t>
             </a:r>
             <a:endParaRPr lang="en-US" sz="3200" dirty="0"/>
           </a:p>
@@ -5179,7 +5174,7 @@
                 <a:ea typeface="Calibri" pitchFamily="34" charset="-122"/>
                 <a:cs typeface="Calibri" pitchFamily="34" charset="-120"/>
               </a:rPr>
-              <a:t>Same scores. Smart Bet also counts a tie for first as a win -- matching the real show rule that co-champions both advance.</a:t>
+              <a:t>Example: you lead with $10,000. Your rivals have $8,000 and $3,400. You are 89% sure of your answer.</a:t>
             </a:r>
             <a:endParaRPr lang="en-US" sz="1400" dirty="0"/>
           </a:p>
@@ -5240,7 +5235,7 @@
                 <a:ea typeface="Calibri" pitchFamily="34" charset="-122"/>
                 <a:cs typeface="Calibri" pitchFamily="34" charset="-120"/>
               </a:rPr>
-              <a:t>AT 50% CONFIDENCE</a:t>
+              <a:t>BEFORE: A TIE COUNTED AS A WIN</a:t>
             </a:r>
             <a:endParaRPr lang="en-US" sz="1300" dirty="0"/>
           </a:p>
@@ -5279,7 +5274,7 @@
                 <a:ea typeface="Cambria" pitchFamily="34" charset="-122"/>
                 <a:cs typeface="Cambria" pitchFamily="34" charset="-120"/>
               </a:rPr>
-              <a:t>$4,000</a:t>
+              <a:t>$6,000</a:t>
             </a:r>
             <a:endParaRPr lang="en-US" sz="4400" dirty="0"/>
           </a:p>
@@ -5318,7 +5313,7 @@
                 <a:ea typeface="Calibri" pitchFamily="34" charset="-122"/>
                 <a:cs typeface="Calibri" pitchFamily="34" charset="-120"/>
               </a:rPr>
-              <a:t>~78% estimated win rate</a:t>
+              <a:t>old Smart Bet: a bet to tie</a:t>
             </a:r>
             <a:endParaRPr lang="en-US" sz="1400" dirty="0"/>
           </a:p>
@@ -5360,7 +5355,7 @@
                 <a:ea typeface="Calibri" pitchFamily="34" charset="-122"/>
                 <a:cs typeface="Calibri" pitchFamily="34" charset="-120"/>
               </a:rPr>
-              <a:t>recommended wager stays the same --</a:t>
+              <a:t>If you and second place both double up,</a:t>
             </a:r>
             <a:endParaRPr lang="en-US" sz="1150" dirty="0"/>
           </a:p>
@@ -5380,7 +5375,7 @@
                 <a:ea typeface="Calibri" pitchFamily="34" charset="-122"/>
                 <a:cs typeface="Calibri" pitchFamily="34" charset="-120"/>
               </a:rPr>
-              <a:t>confidence changes how good the bet is,</a:t>
+              <a:t>you finish level. The old tool used the</a:t>
             </a:r>
             <a:endParaRPr lang="en-US" sz="1150" dirty="0"/>
           </a:p>
@@ -5400,7 +5395,7 @@
                 <a:ea typeface="Calibri" pitchFamily="34" charset="-122"/>
                 <a:cs typeface="Calibri" pitchFamily="34" charset="-120"/>
               </a:rPr>
-              <a:t>not how much to bet here</a:t>
+              <a:t>old co-champion rule and called it a win.</a:t>
             </a:r>
             <a:endParaRPr lang="en-US" sz="1150" dirty="0"/>
           </a:p>
@@ -5461,7 +5456,7 @@
                 <a:ea typeface="Calibri" pitchFamily="34" charset="-122"/>
                 <a:cs typeface="Calibri" pitchFamily="34" charset="-120"/>
               </a:rPr>
-              <a:t>AT 90% CONFIDENCE</a:t>
+              <a:t>NOW: A TIE IS HALF A WIN</a:t>
             </a:r>
             <a:endParaRPr lang="en-US" sz="1300" dirty="0"/>
           </a:p>
@@ -5500,7 +5495,7 @@
                 <a:ea typeface="Cambria" pitchFamily="34" charset="-122"/>
                 <a:cs typeface="Cambria" pitchFamily="34" charset="-120"/>
               </a:rPr>
-              <a:t>$4,000</a:t>
+              <a:t>$6,001</a:t>
             </a:r>
             <a:endParaRPr lang="en-US" sz="4400" dirty="0"/>
           </a:p>
@@ -5539,7 +5534,7 @@
                 <a:ea typeface="Calibri" pitchFamily="34" charset="-122"/>
                 <a:cs typeface="Calibri" pitchFamily="34" charset="-120"/>
               </a:rPr>
-              <a:t>~96% estimated win rate</a:t>
+              <a:t>new Smart Bet: one dollar more wins</a:t>
             </a:r>
             <a:endParaRPr lang="en-US" sz="1400" dirty="0"/>
           </a:p>
@@ -5581,7 +5576,7 @@
                 <a:ea typeface="Calibri" pitchFamily="34" charset="-122"/>
                 <a:cs typeface="Calibri" pitchFamily="34" charset="-120"/>
               </a:rPr>
-              <a:t>recommended wager stays the same --</a:t>
+              <a:t>Since November 2014, a tie for first goes</a:t>
             </a:r>
             <a:endParaRPr lang="en-US" sz="1150" dirty="0"/>
           </a:p>
@@ -5601,7 +5596,7 @@
                 <a:ea typeface="Calibri" pitchFamily="34" charset="-122"/>
                 <a:cs typeface="Calibri" pitchFamily="34" charset="-120"/>
               </a:rPr>
-              <a:t>confidence changes how good the bet is,</a:t>
+              <a:t>to a tiebreaker clue, and only one player</a:t>
             </a:r>
             <a:endParaRPr lang="en-US" sz="1150" dirty="0"/>
           </a:p>
@@ -5621,7 +5616,7 @@
                 <a:ea typeface="Calibri" pitchFamily="34" charset="-122"/>
                 <a:cs typeface="Calibri" pitchFamily="34" charset="-120"/>
               </a:rPr>
-              <a:t>not how much to bet here</a:t>
+              <a:t>comes back. The tool now follows that rule.</a:t>
             </a:r>
             <a:endParaRPr lang="en-US" sz="1150" dirty="0"/>
           </a:p>
@@ -5682,7 +5677,7 @@
                 <a:ea typeface="Cambria" pitchFamily="34" charset="-122"/>
                 <a:cs typeface="Cambria" pitchFamily="34" charset="-120"/>
               </a:rPr>
-              <a:t>A rule worth knowing: never settle for a tie when a win is free.</a:t>
+              <a:t>A rule worth knowing: never settle for a tie when one more dollar wins.</a:t>
             </a:r>
             <a:endParaRPr lang="en-US" sz="1500" dirty="0"/>
           </a:p>
@@ -5724,7 +5719,7 @@
                 <a:ea typeface="Calibri" pitchFamily="34" charset="-122"/>
                 <a:cs typeface="Calibri" pitchFamily="34" charset="-120"/>
               </a:rPr>
-              <a:t>If two wagers reach the same win probability, but one only ties an opponent while the other beats them outright at no extra cost, Smart Bet now always prefers the outright win.</a:t>
+              <a:t>A two-way tie for first now counts as half a win, and a three-way tie as a third. Nobody wins at $0.</a:t>
             </a:r>
             <a:endParaRPr lang="en-US" sz="1250" dirty="0"/>
           </a:p>
@@ -6912,7 +6907,7 @@
                 <a:ea typeface="Calibri" pitchFamily="34" charset="-122"/>
                 <a:cs typeface="Calibri" pitchFamily="34" charset="-120"/>
               </a:rPr>
-              <a:t>AFTER THE FIX -- both confidence levels</a:t>
+              <a:t>AFTER THE FIX -- both confidence levels agree</a:t>
             </a:r>
             <a:endParaRPr lang="en-US" sz="1200" dirty="0"/>
           </a:p>
@@ -6951,7 +6946,7 @@
                 <a:ea typeface="Cambria" pitchFamily="34" charset="-122"/>
                 <a:cs typeface="Cambria" pitchFamily="34" charset="-120"/>
               </a:rPr>
-              <a:t>$0</a:t>
+              <a:t>One answer</a:t>
             </a:r>
             <a:endParaRPr lang="en-US" sz="4600" dirty="0"/>
           </a:p>
@@ -7100,7 +7095,7 @@
                 <a:ea typeface="Cambria" pitchFamily="34" charset="-122"/>
                 <a:cs typeface="Cambria" pitchFamily="34" charset="-120"/>
               </a:rPr>
-              <a:t>Even long shots get modeled correctly</a:t>
+              <a:t>Rivals that bet like real people</a:t>
             </a:r>
             <a:endParaRPr lang="en-US" sz="3200" dirty="0"/>
           </a:p>
@@ -7139,7 +7134,7 @@
                 <a:ea typeface="Calibri" pitchFamily="34" charset="-122"/>
                 <a:cs typeface="Calibri" pitchFamily="34" charset="-120"/>
               </a:rPr>
-              <a:t>You're in 3rd place. Can you still win Final Jeopardy if both leaders bet big and miss?</a:t>
+              <a:t>Smart Bet used to guess rivals' bets with an even split. Now it simulates contestants based on IBM's study of about 3,000 real games.</a:t>
             </a:r>
             <a:endParaRPr lang="en-US" sz="1400" dirty="0"/>
           </a:p>
@@ -7200,7 +7195,7 @@
                 <a:ea typeface="Calibri" pitchFamily="34" charset="-122"/>
                 <a:cs typeface="Calibri" pitchFamily="34" charset="-120"/>
               </a:rPr>
-              <a:t>You</a:t>
+              <a:t>Leader</a:t>
             </a:r>
             <a:endParaRPr lang="en-US" sz="1200" dirty="0"/>
           </a:p>
@@ -7239,7 +7234,7 @@
                 <a:ea typeface="Cambria" pitchFamily="34" charset="-122"/>
                 <a:cs typeface="Cambria" pitchFamily="34" charset="-120"/>
               </a:rPr>
-              <a:t>$4,000</a:t>
+              <a:t>Covers</a:t>
             </a:r>
             <a:endParaRPr lang="en-US" sz="2400" dirty="0"/>
           </a:p>
@@ -7300,7 +7295,7 @@
                 <a:ea typeface="Calibri" pitchFamily="34" charset="-122"/>
                 <a:cs typeface="Calibri" pitchFamily="34" charset="-120"/>
               </a:rPr>
-              <a:t>Rival 1</a:t>
+              <a:t>Second place</a:t>
             </a:r>
             <a:endParaRPr lang="en-US" sz="1200" dirty="0"/>
           </a:p>
@@ -7339,7 +7334,7 @@
                 <a:ea typeface="Cambria" pitchFamily="34" charset="-122"/>
                 <a:cs typeface="Cambria" pitchFamily="34" charset="-120"/>
               </a:rPr>
-              <a:t>$9,000</a:t>
+              <a:t>Mixes it up</a:t>
             </a:r>
             <a:endParaRPr lang="en-US" sz="2400" dirty="0"/>
           </a:p>
@@ -7400,7 +7395,7 @@
                 <a:ea typeface="Calibri" pitchFamily="34" charset="-122"/>
                 <a:cs typeface="Calibri" pitchFamily="34" charset="-120"/>
               </a:rPr>
-              <a:t>Rival 2</a:t>
+              <a:t>Third place</a:t>
             </a:r>
             <a:endParaRPr lang="en-US" sz="1200" dirty="0"/>
           </a:p>
@@ -7439,7 +7434,7 @@
                 <a:ea typeface="Cambria" pitchFamily="34" charset="-122"/>
                 <a:cs typeface="Cambria" pitchFamily="34" charset="-120"/>
               </a:rPr>
-              <a:t>$10,000</a:t>
+              <a:t>No pattern</a:t>
             </a:r>
             <a:endParaRPr lang="en-US" sz="2400" dirty="0"/>
           </a:p>
@@ -7481,7 +7476,7 @@
                 <a:ea typeface="Calibri" pitchFamily="34" charset="-122"/>
                 <a:cs typeface="Calibri" pitchFamily="34" charset="-120"/>
               </a:rPr>
-              <a:t>At 100% self-confidence, the model finds you win exactly when both rivals bet big and get it wrong -- fully independent events.</a:t>
+              <a:t>Leaders usually bet to cover. Second place mixes all-in, keeping third place out, overtaking, and the small "two-thirds" bet. Third place bets with no pattern.</a:t>
             </a:r>
             <a:endParaRPr lang="en-US" sz="1400" dirty="0"/>
           </a:p>
@@ -7542,7 +7537,7 @@
                 <a:ea typeface="Cambria" pitchFamily="34" charset="-122"/>
                 <a:cs typeface="Cambria" pitchFamily="34" charset="-120"/>
               </a:rPr>
-              <a:t>1 in 12</a:t>
+              <a:t>Half</a:t>
             </a:r>
             <a:endParaRPr lang="en-US" sz="4800" dirty="0"/>
           </a:p>
@@ -7581,7 +7576,7 @@
                 <a:ea typeface="Calibri" pitchFamily="34" charset="-122"/>
                 <a:cs typeface="Calibri" pitchFamily="34" charset="-120"/>
               </a:rPr>
-              <a:t>~8.3% chance to win from 3rd place</a:t>
+              <a:t>Rivals are right half the time</a:t>
             </a:r>
             <a:endParaRPr lang="en-US" sz="1300" dirty="0"/>
           </a:p>
@@ -7595,8 +7590,8 @@
         </p:nvSpPr>
         <p:spPr>
           <a:xfrm>
-            <a:off x="3794760" y="5394960"/>
-            <a:ext cx="4572000" cy="411480"/>
+            <a:off x="3749040" y="5394960"/>
+            <a:ext cx="4663440" cy="411480"/>
           </a:xfrm>
           <a:prstGeom prst="rect">
             <a:avLst/>
@@ -7620,7 +7615,7 @@
                 <a:ea typeface="Calibri" pitchFamily="34" charset="-122"/>
                 <a:cs typeface="Calibri" pitchFamily="34" charset="-120"/>
               </a:rPr>
-              <a:t>matches the exact number the app showed -- verified by hand, not just by the code's own output</a:t>
+              <a:t>A hard clue is hard for everyone. Some weights are published (Tesauro et al., 2013); the rest are labeled assumptions.</a:t>
             </a:r>
             <a:endParaRPr lang="en-US" sz="1100" dirty="0"/>
           </a:p>

</xml_diff>

<commit_message>
2.1.0: modern-era rivals; underwagering thesis
Recalibrate the simulated contestants from Tesauro (1990s-2012) to
modern-era play (Seasons 38-41): FJ accuracy by score rank, outcome
correlation, leader cover share, DD accuracy, DD wager fraction by round,
DD finder by score rank; future DDs fall among the remaining clues.
Calibrated privately on J! Archive season statistics, which are not
republished (ADR-0004).

Add docs/thesis/underwagering.md: why strong players underwager, the
counter-evidence, the measured cost, and when betting less is right.

Co-Authored-By: Claude Opus 5.5 <noreply@anthropic.com>
</commit_message>
<xml_diff>
--- a/docs/deck.pptx
+++ b/docs/deck.pptx
@@ -2510,7 +2510,7 @@
                 <a:ea typeface="Calibri" pitchFamily="34" charset="-122"/>
                 <a:cs typeface="Calibri" pitchFamily="34" charset="-120"/>
               </a:rPr>
-              <a:t>How rivals bet -- based on IBM's study of real games; some weights published, the rest labeled assumptions</a:t>
+              <a:t>How rivals bet and answer -- matched to recent seasons; second place's mix still from IBM's older study</a:t>
             </a:r>
             <a:endParaRPr lang="en-US" sz="1300" dirty="0"/>
           </a:p>
@@ -7095,7 +7095,7 @@
                 <a:ea typeface="Cambria" pitchFamily="34" charset="-122"/>
                 <a:cs typeface="Cambria" pitchFamily="34" charset="-120"/>
               </a:rPr>
-              <a:t>Rivals that bet like real people</a:t>
+              <a:t>Rivals that play like today's contestants</a:t>
             </a:r>
             <a:endParaRPr lang="en-US" sz="3200" dirty="0"/>
           </a:p>
@@ -7134,7 +7134,7 @@
                 <a:ea typeface="Calibri" pitchFamily="34" charset="-122"/>
                 <a:cs typeface="Calibri" pitchFamily="34" charset="-120"/>
               </a:rPr>
-              <a:t>Smart Bet used to guess rivals' bets with an even split. Now it simulates contestants based on IBM's study of about 3,000 real games.</a:t>
+              <a:t>Smart Bet's rivals now play like contestants from recent seasons, not like the 1990s-2012 games in IBM's older study.</a:t>
             </a:r>
             <a:endParaRPr lang="en-US" sz="1400" dirty="0"/>
           </a:p>
@@ -7476,7 +7476,7 @@
                 <a:ea typeface="Calibri" pitchFamily="34" charset="-122"/>
                 <a:cs typeface="Calibri" pitchFamily="34" charset="-120"/>
               </a:rPr>
-              <a:t>Leaders usually bet to cover. Second place mixes all-in, keeping third place out, overtaking, and the small "two-thirds" bet. Third place bets with no pattern.</a:t>
+              <a:t>The leader almost always bets to cover second place. Second place mixes all-in, keeping third out, overtaking and the small "two-thirds" bet -- that mix still comes from IBM's older study. Third place bets with no pattern.</a:t>
             </a:r>
             <a:endParaRPr lang="en-US" sz="1400" dirty="0"/>
           </a:p>
@@ -7537,7 +7537,7 @@
                 <a:ea typeface="Cambria" pitchFamily="34" charset="-122"/>
                 <a:cs typeface="Cambria" pitchFamily="34" charset="-120"/>
               </a:rPr>
-              <a:t>Half</a:t>
+              <a:t>Modern</a:t>
             </a:r>
             <a:endParaRPr lang="en-US" sz="4800" dirty="0"/>
           </a:p>
@@ -7576,7 +7576,7 @@
                 <a:ea typeface="Calibri" pitchFamily="34" charset="-122"/>
                 <a:cs typeface="Calibri" pitchFamily="34" charset="-120"/>
               </a:rPr>
-              <a:t>Rivals are right half the time</a:t>
+              <a:t>Rivals play like recent seasons</a:t>
             </a:r>
             <a:endParaRPr lang="en-US" sz="1300" dirty="0"/>
           </a:p>
@@ -7615,7 +7615,7 @@
                 <a:ea typeface="Calibri" pitchFamily="34" charset="-122"/>
                 <a:cs typeface="Calibri" pitchFamily="34" charset="-120"/>
               </a:rPr>
-              <a:t>A hard clue is hard for everyone. Some weights are published (Tesauro et al., 2013); the rest are labeled assumptions.</a:t>
+              <a:t>They hunt Daily Doubles and bet them hard. Leaders are right more often. A hard clue is hard for everyone.</a:t>
             </a:r>
             <a:endParaRPr lang="en-US" sz="1100" dirty="0"/>
           </a:p>

</xml_diff>

<commit_message>
2.2.0: rank wagers by win chance, then expected winnings
A solo game at 100% confidence recommended $0: every wager tied on win
chance and ties went to the smallest. The winner keeps their total, so
ties now go to the highest expected winnings. Tier 2 also tries every
breakpoint against opponent outcomes; DD exact ties are chosen by money.
Docs, deck and PDFs updated with the moved figures.

Co-Authored-By: Claude Opus 5.5 <noreply@anthropic.com>
</commit_message>
<xml_diff>
--- a/docs/deck.pptx
+++ b/docs/deck.pptx
@@ -5495,7 +5495,7 @@
                 <a:ea typeface="Cambria" pitchFamily="34" charset="-122"/>
                 <a:cs typeface="Cambria" pitchFamily="34" charset="-120"/>
               </a:rPr>
-              <a:t>$6,001</a:t>
+              <a:t>$6,599</a:t>
             </a:r>
             <a:endParaRPr lang="en-US" sz="4400" dirty="0"/>
           </a:p>
@@ -5534,7 +5534,7 @@
                 <a:ea typeface="Calibri" pitchFamily="34" charset="-122"/>
                 <a:cs typeface="Calibri" pitchFamily="34" charset="-120"/>
               </a:rPr>
-              <a:t>new Smart Bet: one dollar more wins</a:t>
+              <a:t>new Smart Bet: wins outright, keeps a cushion</a:t>
             </a:r>
             <a:endParaRPr lang="en-US" sz="1400" dirty="0"/>
           </a:p>
@@ -5576,7 +5576,7 @@
                 <a:ea typeface="Calibri" pitchFamily="34" charset="-122"/>
                 <a:cs typeface="Calibri" pitchFamily="34" charset="-120"/>
               </a:rPr>
-              <a:t>Since November 2014, a tie for first goes</a:t>
+              <a:t>A tie now goes to a tiebreaker clue, so the</a:t>
             </a:r>
             <a:endParaRPr lang="en-US" sz="1150" dirty="0"/>
           </a:p>
@@ -5596,7 +5596,7 @@
                 <a:ea typeface="Calibri" pitchFamily="34" charset="-122"/>
                 <a:cs typeface="Calibri" pitchFamily="34" charset="-120"/>
               </a:rPr>
-              <a:t>to a tiebreaker clue, and only one player</a:t>
+              <a:t>tool bets enough to beat second place.</a:t>
             </a:r>
             <a:endParaRPr lang="en-US" sz="1150" dirty="0"/>
           </a:p>
@@ -5616,7 +5616,7 @@
                 <a:ea typeface="Calibri" pitchFamily="34" charset="-122"/>
                 <a:cs typeface="Calibri" pitchFamily="34" charset="-120"/>
               </a:rPr>
-              <a:t>comes back. The tool now follows that rule.</a:t>
+              <a:t>If you miss, your $3,401 stays above third's $3,400.</a:t>
             </a:r>
             <a:endParaRPr lang="en-US" sz="1150" dirty="0"/>
           </a:p>

</xml_diff>

<commit_message>
2.2.1: triple-check Final Jeopardy logic, sources and paper math
Tier 1 now has a brute-force test over every legal wager on small games,
plus hand-derived tests of the shut-out, two-thirds and lockout rules.
Tier 2 agrees with an independent implementation to 3.3e-10 (609 states)
and with Monte Carlo sampling. Corrects the backwards two-thirds rule in
the research memo, the lock-tie "guarantee", and several citations
(Dupee 1998, tie-rule date, Tesauro data years and correlation, Masters).
No recommendation or win share moves.

Co-Authored-By: Claude Opus 5.5 <noreply@anthropic.com>
</commit_message>
<xml_diff>
--- a/docs/deck.pptx
+++ b/docs/deck.pptx
@@ -7134,7 +7134,7 @@
                 <a:ea typeface="Calibri" pitchFamily="34" charset="-122"/>
                 <a:cs typeface="Calibri" pitchFamily="34" charset="-120"/>
               </a:rPr>
-              <a:t>Smart Bet's rivals now play like contestants from recent seasons, not like the 1990s-2012 games in IBM's older study.</a:t>
+              <a:t>Smart Bet's rivals now play like contestants from recent seasons, not like the pre-2013 games in IBM's older study.</a:t>
             </a:r>
             <a:endParaRPr lang="en-US" sz="1400" dirty="0"/>
           </a:p>
@@ -7161,6 +7161,10 @@
           </a:solidFill>
           <a:ln/>
         </p:spPr>
+        <p:txBody>
+          <a:bodyPr/>
+          <a:p/>
+        </p:txBody>
       </p:sp>
       <p:sp>
         <p:nvSpPr>
@@ -7261,6 +7265,10 @@
           </a:solidFill>
           <a:ln/>
         </p:spPr>
+        <p:txBody>
+          <a:bodyPr/>
+          <a:p/>
+        </p:txBody>
       </p:sp>
       <p:sp>
         <p:nvSpPr>
@@ -7361,6 +7369,10 @@
           </a:solidFill>
           <a:ln/>
         </p:spPr>
+        <p:txBody>
+          <a:bodyPr/>
+          <a:p/>
+        </p:txBody>
       </p:sp>
       <p:sp>
         <p:nvSpPr>
@@ -7434,7 +7446,7 @@
                 <a:ea typeface="Cambria" pitchFamily="34" charset="-122"/>
                 <a:cs typeface="Cambria" pitchFamily="34" charset="-120"/>
               </a:rPr>
-              <a:t>No pattern</a:t>
+              <a:t>Ignores the scores</a:t>
             </a:r>
             <a:endParaRPr lang="en-US" sz="2400" dirty="0"/>
           </a:p>
@@ -7476,7 +7488,7 @@
                 <a:ea typeface="Calibri" pitchFamily="34" charset="-122"/>
                 <a:cs typeface="Calibri" pitchFamily="34" charset="-120"/>
               </a:rPr>
-              <a:t>The leader almost always bets to cover second place. Second place mixes all-in, keeping third out, overtaking and the small "two-thirds" bet -- that mix still comes from IBM's older study. Third place bets with no pattern.</a:t>
+              <a:t>The leader almost always bets to cover second place. Second place mixes all-in, keeping third out, overtaking and the small "two-thirds" bet -- that mix still comes from IBM's older study. Third place's bets don't track the scores.</a:t>
             </a:r>
             <a:endParaRPr lang="en-US" sz="1400" dirty="0"/>
           </a:p>
@@ -7503,6 +7515,10 @@
           </a:solidFill>
           <a:ln/>
         </p:spPr>
+        <p:txBody>
+          <a:bodyPr/>
+          <a:p/>
+        </p:txBody>
       </p:sp>
       <p:sp>
         <p:nvSpPr>

</xml_diff>